<commit_message>
Add document ingestion and reproducible RAG experiments
</commit_message>
<xml_diff>
--- a/Local_RAG_Project_Presentation.pptx
+++ b/Local_RAG_Project_Presentation.pptx
@@ -15,7 +15,8 @@
     <p:sldId id="263" r:id="rId9"/>
     <p:sldId id="264" r:id="rId10"/>
     <p:sldId id="265" r:id="rId11"/>
-    <p:sldId id="266" r:id="rId12"/>
+    <p:sldId id="267" r:id="rId12"/>
+    <p:sldId id="266" r:id="rId13"/>
   </p:sldIdLst>
   <p:sldSz cx="12192000" cy="6858000"/>
   <p:notesSz cx="6858000" cy="9144000"/>
@@ -3225,7 +3226,7 @@
         </p:spPr>
         <p:txBody>
           <a:bodyPr wrap="square" lIns="73152" tIns="36576" rIns="73152" bIns="36576" anchor="ctr">
-            <a:normAutofit/>
+            <a:normAutofit lnSpcReduction="10000"/>
           </a:bodyPr>
           <a:lstStyle/>
           <a:p>
@@ -3975,7 +3976,7 @@
         </p:spPr>
         <p:txBody>
           <a:bodyPr wrap="square" lIns="73152" tIns="36576" rIns="73152" bIns="36576" anchor="ctr">
-            <a:normAutofit/>
+            <a:normAutofit lnSpcReduction="10000"/>
           </a:bodyPr>
           <a:lstStyle/>
           <a:p>
@@ -4185,7 +4186,7 @@
         </p:spPr>
         <p:txBody>
           <a:bodyPr wrap="square" lIns="73152" tIns="36576" rIns="73152" bIns="36576" anchor="ctr">
-            <a:normAutofit/>
+            <a:normAutofit lnSpcReduction="10000"/>
           </a:bodyPr>
           <a:lstStyle/>
           <a:p>
@@ -4357,7 +4358,7 @@
         </p:spPr>
         <p:txBody>
           <a:bodyPr wrap="square" lIns="73152" tIns="36576" rIns="73152" bIns="36576" anchor="ctr">
-            <a:normAutofit/>
+            <a:normAutofit lnSpcReduction="10000"/>
           </a:bodyPr>
           <a:lstStyle/>
           <a:p>
@@ -4529,7 +4530,7 @@
         </p:spPr>
         <p:txBody>
           <a:bodyPr wrap="square" lIns="73152" tIns="36576" rIns="73152" bIns="36576" anchor="ctr">
-            <a:normAutofit/>
+            <a:normAutofit lnSpcReduction="10000"/>
           </a:bodyPr>
           <a:lstStyle/>
           <a:p>
@@ -4605,7 +4606,7 @@
         </p:spPr>
         <p:txBody>
           <a:bodyPr wrap="square" lIns="73152" tIns="36576" rIns="73152" bIns="36576" anchor="ctr">
-            <a:normAutofit/>
+            <a:normAutofit lnSpcReduction="10000"/>
           </a:bodyPr>
           <a:lstStyle/>
           <a:p>
@@ -5195,6 +5196,105 @@
 </file>
 
 <file path=ppt/slides/slide11.xml><?xml version="1.0" encoding="utf-8"?>
+<p:sld xmlns:a="http://schemas.openxmlformats.org/drawingml/2006/main" xmlns:r="http://schemas.openxmlformats.org/officeDocument/2006/relationships" xmlns:p="http://schemas.openxmlformats.org/presentationml/2006/main">
+  <p:cSld>
+    <p:spTree>
+      <p:nvGrpSpPr>
+        <p:cNvPr id="1" name=""/>
+        <p:cNvGrpSpPr/>
+        <p:nvPr/>
+      </p:nvGrpSpPr>
+      <p:grpSpPr>
+        <a:xfrm>
+          <a:off x="0" y="0"/>
+          <a:ext cx="0" cy="0"/>
+          <a:chOff x="0" y="0"/>
+          <a:chExt cx="0" cy="0"/>
+        </a:xfrm>
+      </p:grpSpPr>
+      <p:pic>
+        <p:nvPicPr>
+          <p:cNvPr id="2" name="Picture 1" descr="Local_RAG_Experiment_Results.png"/>
+          <p:cNvPicPr>
+            <a:picLocks noChangeAspect="1"/>
+          </p:cNvPicPr>
+          <p:nvPr/>
+        </p:nvPicPr>
+        <p:blipFill>
+          <a:blip r:embed="rId2"/>
+          <a:stretch>
+            <a:fillRect/>
+          </a:stretch>
+        </p:blipFill>
+        <p:spPr>
+          <a:xfrm>
+            <a:off x="0" y="0"/>
+            <a:ext cx="12192000" cy="6858000"/>
+          </a:xfrm>
+          <a:prstGeom prst="rect">
+            <a:avLst/>
+          </a:prstGeom>
+        </p:spPr>
+      </p:pic>
+      <p:sp>
+        <p:nvSpPr>
+          <p:cNvPr id="3" name="TextBox 2">
+            <a:extLst>
+              <a:ext uri="{FF2B5EF4-FFF2-40B4-BE49-F238E27FC236}">
+                <a16:creationId xmlns:a16="http://schemas.microsoft.com/office/drawing/2014/main" id="{E5DB6CE4-34A3-49D8-8EBB-89D2F9950B8C}"/>
+              </a:ext>
+            </a:extLst>
+          </p:cNvPr>
+          <p:cNvSpPr txBox="1"/>
+          <p:nvPr/>
+        </p:nvSpPr>
+        <p:spPr>
+          <a:xfrm>
+            <a:off x="11292840" y="320040"/>
+            <a:ext cx="365760" cy="365760"/>
+          </a:xfrm>
+          <a:prstGeom prst="roundRect">
+            <a:avLst/>
+          </a:prstGeom>
+          <a:noFill/>
+          <a:ln>
+            <a:solidFill/>
+          </a:ln>
+        </p:spPr>
+        <p:txBody>
+          <a:bodyPr wrap="square" lIns="73152" tIns="36576" rIns="73152" bIns="36576" anchor="ctr">
+            <a:normAutofit/>
+          </a:bodyPr>
+          <a:lstStyle/>
+          <a:p>
+            <a:pPr algn="r"/>
+            <a:r>
+              <a:rPr lang="ru-RU" sz="1200" b="1" dirty="0">
+                <a:solidFill>
+                  <a:srgbClr val="FFFFFF"/>
+                </a:solidFill>
+                <a:latin typeface="Aptos"/>
+              </a:rPr>
+              <a:t>11</a:t>
+            </a:r>
+            <a:endParaRPr sz="1200" b="1" dirty="0">
+              <a:solidFill>
+                <a:srgbClr val="FFFFFF"/>
+              </a:solidFill>
+              <a:latin typeface="Aptos"/>
+            </a:endParaRPr>
+          </a:p>
+        </p:txBody>
+      </p:sp>
+    </p:spTree>
+  </p:cSld>
+  <p:clrMapOvr>
+    <a:masterClrMapping/>
+  </p:clrMapOvr>
+</p:sld>
+</file>
+
+<file path=ppt/slides/slide12.xml><?xml version="1.0" encoding="utf-8"?>
 <p:sld xmlns:a="http://schemas.openxmlformats.org/drawingml/2006/main" xmlns:r="http://schemas.openxmlformats.org/officeDocument/2006/relationships" xmlns:p="http://schemas.openxmlformats.org/presentationml/2006/main">
   <p:cSld>
     <p:bg>
@@ -5288,7 +5388,7 @@
         </p:spPr>
         <p:txBody>
           <a:bodyPr wrap="square" lIns="73152" tIns="36576" rIns="73152" bIns="36576" anchor="ctr">
-            <a:normAutofit/>
+            <a:normAutofit lnSpcReduction="10000"/>
           </a:bodyPr>
           <a:lstStyle/>
           <a:p>
@@ -5370,14 +5470,20 @@
           <a:p>
             <a:pPr algn="r"/>
             <a:r>
-              <a:rPr sz="1200" b="1">
-                <a:solidFill>
-                  <a:srgbClr val="FFFFFF"/>
-                </a:solidFill>
-                <a:latin typeface="Aptos"/>
-              </a:rPr>
-              <a:t>11</a:t>
-            </a:r>
+              <a:rPr lang="ru-RU" sz="1200" b="1" dirty="0">
+                <a:solidFill>
+                  <a:srgbClr val="FFFFFF"/>
+                </a:solidFill>
+                <a:latin typeface="Aptos"/>
+              </a:rPr>
+              <a:t>12</a:t>
+            </a:r>
+            <a:endParaRPr sz="1200" b="1" dirty="0">
+              <a:solidFill>
+                <a:srgbClr val="FFFFFF"/>
+              </a:solidFill>
+              <a:latin typeface="Aptos"/>
+            </a:endParaRPr>
           </a:p>
         </p:txBody>
       </p:sp>
@@ -5402,7 +5508,7 @@
         </p:spPr>
         <p:txBody>
           <a:bodyPr wrap="square" lIns="73152" tIns="36576" rIns="73152" bIns="36576" anchor="ctr">
-            <a:normAutofit/>
+            <a:normAutofit fontScale="92500" lnSpcReduction="20000"/>
           </a:bodyPr>
           <a:lstStyle/>
           <a:p>
@@ -5576,7 +5682,7 @@
         </p:spPr>
         <p:txBody>
           <a:bodyPr wrap="square" lIns="73152" tIns="36576" rIns="73152" bIns="36576" anchor="ctr">
-            <a:normAutofit/>
+            <a:normAutofit fontScale="92500" lnSpcReduction="20000"/>
           </a:bodyPr>
           <a:lstStyle/>
           <a:p>
@@ -5798,7 +5904,7 @@
         </p:spPr>
         <p:txBody>
           <a:bodyPr wrap="square" lIns="73152" tIns="36576" rIns="73152" bIns="36576" anchor="ctr">
-            <a:normAutofit/>
+            <a:normAutofit fontScale="92500" lnSpcReduction="20000"/>
           </a:bodyPr>
           <a:lstStyle/>
           <a:p>
@@ -6137,7 +6243,7 @@
         </p:spPr>
         <p:txBody>
           <a:bodyPr wrap="square" lIns="73152" tIns="36576" rIns="73152" bIns="36576" anchor="ctr">
-            <a:normAutofit/>
+            <a:normAutofit lnSpcReduction="10000"/>
           </a:bodyPr>
           <a:lstStyle/>
           <a:p>
@@ -6347,7 +6453,7 @@
         </p:spPr>
         <p:txBody>
           <a:bodyPr wrap="square" lIns="73152" tIns="36576" rIns="73152" bIns="36576" anchor="ctr">
-            <a:normAutofit/>
+            <a:normAutofit lnSpcReduction="10000"/>
           </a:bodyPr>
           <a:lstStyle/>
           <a:p>
@@ -7446,7 +7552,7 @@
         </p:spPr>
         <p:txBody>
           <a:bodyPr wrap="square" lIns="73152" tIns="36576" rIns="73152" bIns="36576" anchor="ctr">
-            <a:normAutofit/>
+            <a:normAutofit lnSpcReduction="10000"/>
           </a:bodyPr>
           <a:lstStyle/>
           <a:p>
@@ -7922,7 +8028,7 @@
         </p:spPr>
         <p:txBody>
           <a:bodyPr wrap="square" lIns="73152" tIns="36576" rIns="73152" bIns="36576" anchor="ctr">
-            <a:normAutofit/>
+            <a:normAutofit lnSpcReduction="10000"/>
           </a:bodyPr>
           <a:lstStyle/>
           <a:p>
@@ -8810,7 +8916,7 @@
         </p:spPr>
         <p:txBody>
           <a:bodyPr wrap="square" lIns="73152" tIns="36576" rIns="73152" bIns="36576" anchor="ctr">
-            <a:normAutofit/>
+            <a:normAutofit fontScale="92500" lnSpcReduction="20000"/>
           </a:bodyPr>
           <a:lstStyle/>
           <a:p>
@@ -8848,7 +8954,7 @@
         </p:spPr>
         <p:txBody>
           <a:bodyPr wrap="square" lIns="73152" tIns="36576" rIns="73152" bIns="36576" anchor="ctr">
-            <a:normAutofit/>
+            <a:normAutofit fontScale="92500" lnSpcReduction="20000"/>
           </a:bodyPr>
           <a:lstStyle/>
           <a:p>
@@ -8886,7 +8992,7 @@
         </p:spPr>
         <p:txBody>
           <a:bodyPr wrap="square" lIns="73152" tIns="36576" rIns="73152" bIns="36576" anchor="ctr">
-            <a:normAutofit/>
+            <a:normAutofit fontScale="92500" lnSpcReduction="20000"/>
           </a:bodyPr>
           <a:lstStyle/>
           <a:p>
@@ -8924,7 +9030,7 @@
         </p:spPr>
         <p:txBody>
           <a:bodyPr wrap="square" lIns="73152" tIns="36576" rIns="73152" bIns="36576" anchor="ctr">
-            <a:normAutofit/>
+            <a:normAutofit fontScale="92500" lnSpcReduction="20000"/>
           </a:bodyPr>
           <a:lstStyle/>
           <a:p>
@@ -8962,7 +9068,7 @@
         </p:spPr>
         <p:txBody>
           <a:bodyPr wrap="square" lIns="73152" tIns="36576" rIns="73152" bIns="36576" anchor="ctr">
-            <a:normAutofit/>
+            <a:normAutofit fontScale="92500" lnSpcReduction="20000"/>
           </a:bodyPr>
           <a:lstStyle/>
           <a:p>
@@ -9000,7 +9106,7 @@
         </p:spPr>
         <p:txBody>
           <a:bodyPr wrap="square" lIns="73152" tIns="36576" rIns="73152" bIns="36576" anchor="ctr">
-            <a:normAutofit/>
+            <a:normAutofit fontScale="92500" lnSpcReduction="20000"/>
           </a:bodyPr>
           <a:lstStyle/>
           <a:p>
@@ -9038,7 +9144,7 @@
         </p:spPr>
         <p:txBody>
           <a:bodyPr wrap="square" lIns="73152" tIns="36576" rIns="73152" bIns="36576" anchor="ctr">
-            <a:normAutofit/>
+            <a:normAutofit fontScale="92500" lnSpcReduction="20000"/>
           </a:bodyPr>
           <a:lstStyle/>
           <a:p>
@@ -9530,7 +9636,7 @@
         </p:spPr>
         <p:txBody>
           <a:bodyPr wrap="square" lIns="73152" tIns="36576" rIns="73152" bIns="36576" anchor="ctr">
-            <a:normAutofit/>
+            <a:normAutofit lnSpcReduction="10000"/>
           </a:bodyPr>
           <a:lstStyle/>
           <a:p>
@@ -9834,7 +9940,7 @@
         </p:spPr>
         <p:txBody>
           <a:bodyPr wrap="square" lIns="73152" tIns="36576" rIns="73152" bIns="36576" anchor="ctr">
-            <a:normAutofit/>
+            <a:normAutofit fontScale="92500" lnSpcReduction="20000"/>
           </a:bodyPr>
           <a:lstStyle/>
           <a:p>
@@ -10038,7 +10144,7 @@
         </p:spPr>
         <p:txBody>
           <a:bodyPr wrap="square" lIns="73152" tIns="36576" rIns="73152" bIns="36576" anchor="ctr">
-            <a:normAutofit/>
+            <a:normAutofit lnSpcReduction="10000"/>
           </a:bodyPr>
           <a:lstStyle/>
           <a:p>
@@ -10473,7 +10579,7 @@
         </p:spPr>
         <p:txBody>
           <a:bodyPr wrap="square" lIns="73152" tIns="36576" rIns="73152" bIns="36576" anchor="ctr">
-            <a:normAutofit/>
+            <a:normAutofit fontScale="92500" lnSpcReduction="20000"/>
           </a:bodyPr>
           <a:lstStyle/>
           <a:p>
@@ -10511,7 +10617,7 @@
         </p:spPr>
         <p:txBody>
           <a:bodyPr wrap="square" lIns="73152" tIns="36576" rIns="73152" bIns="36576" anchor="ctr">
-            <a:normAutofit/>
+            <a:normAutofit lnSpcReduction="10000"/>
           </a:bodyPr>
           <a:lstStyle/>
           <a:p>
@@ -10549,7 +10655,7 @@
         </p:spPr>
         <p:txBody>
           <a:bodyPr wrap="square" lIns="73152" tIns="36576" rIns="73152" bIns="36576" anchor="ctr">
-            <a:normAutofit/>
+            <a:normAutofit fontScale="92500" lnSpcReduction="20000"/>
           </a:bodyPr>
           <a:lstStyle/>
           <a:p>
@@ -10669,7 +10775,7 @@
         </p:spPr>
         <p:txBody>
           <a:bodyPr wrap="square" lIns="73152" tIns="36576" rIns="73152" bIns="36576" anchor="ctr">
-            <a:normAutofit/>
+            <a:normAutofit fontScale="92500" lnSpcReduction="20000"/>
           </a:bodyPr>
           <a:lstStyle/>
           <a:p>
@@ -11124,7 +11230,7 @@
         </p:spPr>
         <p:txBody>
           <a:bodyPr wrap="square" lIns="73152" tIns="36576" rIns="73152" bIns="36576" anchor="ctr">
-            <a:normAutofit/>
+            <a:normAutofit lnSpcReduction="10000"/>
           </a:bodyPr>
           <a:lstStyle/>
           <a:p>
@@ -11412,7 +11518,7 @@
         </p:spPr>
         <p:txBody>
           <a:bodyPr wrap="square" lIns="73152" tIns="36576" rIns="73152" bIns="36576" anchor="ctr">
-            <a:normAutofit/>
+            <a:normAutofit lnSpcReduction="10000"/>
           </a:bodyPr>
           <a:lstStyle/>
           <a:p>
@@ -11701,7 +11807,7 @@
         </p:spPr>
         <p:txBody>
           <a:bodyPr wrap="square" lIns="73152" tIns="36576" rIns="73152" bIns="36576" anchor="ctr">
-            <a:normAutofit/>
+            <a:normAutofit lnSpcReduction="10000"/>
           </a:bodyPr>
           <a:lstStyle/>
           <a:p>
@@ -12017,7 +12123,7 @@
         </p:spPr>
         <p:txBody>
           <a:bodyPr wrap="square" lIns="73152" tIns="36576" rIns="73152" bIns="36576" anchor="ctr">
-            <a:normAutofit/>
+            <a:normAutofit lnSpcReduction="10000"/>
           </a:bodyPr>
           <a:lstStyle/>
           <a:p>
@@ -12255,7 +12361,7 @@
         </p:spPr>
         <p:txBody>
           <a:bodyPr wrap="square" lIns="73152" tIns="36576" rIns="73152" bIns="36576" anchor="ctr">
-            <a:normAutofit/>
+            <a:normAutofit lnSpcReduction="10000"/>
           </a:bodyPr>
           <a:lstStyle/>
           <a:p>
@@ -12502,7 +12608,7 @@
         </p:spPr>
         <p:txBody>
           <a:bodyPr wrap="square" lIns="73152" tIns="36576" rIns="73152" bIns="36576" anchor="ctr">
-            <a:normAutofit/>
+            <a:normAutofit lnSpcReduction="10000"/>
           </a:bodyPr>
           <a:lstStyle/>
           <a:p>
@@ -13086,7 +13192,7 @@
         </p:spPr>
         <p:txBody>
           <a:bodyPr wrap="square" lIns="73152" tIns="36576" rIns="73152" bIns="36576" anchor="ctr">
-            <a:normAutofit/>
+            <a:normAutofit lnSpcReduction="10000"/>
           </a:bodyPr>
           <a:lstStyle/>
           <a:p>
@@ -13296,7 +13402,7 @@
         </p:spPr>
         <p:txBody>
           <a:bodyPr wrap="square" lIns="73152" tIns="36576" rIns="73152" bIns="36576" anchor="ctr">
-            <a:normAutofit/>
+            <a:normAutofit lnSpcReduction="10000"/>
           </a:bodyPr>
           <a:lstStyle/>
           <a:p>
@@ -13470,7 +13576,7 @@
         </p:spPr>
         <p:txBody>
           <a:bodyPr wrap="square" lIns="73152" tIns="36576" rIns="73152" bIns="36576" anchor="ctr">
-            <a:normAutofit/>
+            <a:normAutofit lnSpcReduction="10000"/>
           </a:bodyPr>
           <a:lstStyle/>
           <a:p>
@@ -13749,7 +13855,7 @@
         </p:spPr>
         <p:txBody>
           <a:bodyPr wrap="square" lIns="73152" tIns="36576" rIns="73152" bIns="36576" anchor="ctr">
-            <a:normAutofit/>
+            <a:normAutofit lnSpcReduction="10000"/>
           </a:bodyPr>
           <a:lstStyle/>
           <a:p>
@@ -13928,7 +14034,7 @@
         </p:spPr>
         <p:txBody>
           <a:bodyPr wrap="square" lIns="73152" tIns="36576" rIns="73152" bIns="36576" anchor="ctr">
-            <a:normAutofit/>
+            <a:normAutofit fontScale="92500" lnSpcReduction="10000"/>
           </a:bodyPr>
           <a:lstStyle/>
           <a:p>
@@ -14040,7 +14146,7 @@
         </p:spPr>
         <p:txBody>
           <a:bodyPr wrap="square" lIns="73152" tIns="36576" rIns="73152" bIns="36576" anchor="ctr">
-            <a:normAutofit/>
+            <a:normAutofit fontScale="92500" lnSpcReduction="10000"/>
           </a:bodyPr>
           <a:lstStyle/>
           <a:p>
@@ -14450,7 +14556,7 @@
         </p:spPr>
         <p:txBody>
           <a:bodyPr wrap="square" lIns="73152" tIns="36576" rIns="73152" bIns="36576" anchor="ctr">
-            <a:normAutofit/>
+            <a:normAutofit lnSpcReduction="10000"/>
           </a:bodyPr>
           <a:lstStyle/>
           <a:p>
@@ -14612,7 +14718,7 @@
         </p:spPr>
         <p:txBody>
           <a:bodyPr wrap="square" lIns="73152" tIns="36576" rIns="73152" bIns="36576" anchor="ctr">
-            <a:normAutofit/>
+            <a:normAutofit fontScale="92500" lnSpcReduction="10000"/>
           </a:bodyPr>
           <a:lstStyle/>
           <a:p>
@@ -14692,7 +14798,7 @@
         </p:spPr>
         <p:txBody>
           <a:bodyPr wrap="square" lIns="73152" tIns="36576" rIns="73152" bIns="36576" anchor="ctr">
-            <a:normAutofit/>
+            <a:normAutofit lnSpcReduction="10000"/>
           </a:bodyPr>
           <a:lstStyle/>
           <a:p>
@@ -14826,7 +14932,7 @@
         </p:spPr>
         <p:txBody>
           <a:bodyPr wrap="square" lIns="73152" tIns="36576" rIns="73152" bIns="36576" anchor="ctr">
-            <a:normAutofit/>
+            <a:normAutofit lnSpcReduction="10000"/>
           </a:bodyPr>
           <a:lstStyle/>
           <a:p>
@@ -14998,7 +15104,7 @@
         </p:spPr>
         <p:txBody>
           <a:bodyPr wrap="square" lIns="73152" tIns="36576" rIns="73152" bIns="36576" anchor="ctr">
-            <a:normAutofit/>
+            <a:normAutofit lnSpcReduction="10000"/>
           </a:bodyPr>
           <a:lstStyle/>
           <a:p>
@@ -15170,7 +15276,7 @@
         </p:spPr>
         <p:txBody>
           <a:bodyPr wrap="square" lIns="73152" tIns="36576" rIns="73152" bIns="36576" anchor="ctr">
-            <a:normAutofit/>
+            <a:normAutofit lnSpcReduction="10000"/>
           </a:bodyPr>
           <a:lstStyle/>
           <a:p>
@@ -15547,7 +15653,7 @@
         </p:spPr>
         <p:txBody>
           <a:bodyPr wrap="square" lIns="73152" tIns="36576" rIns="73152" bIns="36576" anchor="ctr">
-            <a:normAutofit/>
+            <a:normAutofit lnSpcReduction="10000"/>
           </a:bodyPr>
           <a:lstStyle/>
           <a:p>
@@ -16405,7 +16511,7 @@
         </p:spPr>
         <p:txBody>
           <a:bodyPr wrap="square" lIns="73152" tIns="36576" rIns="73152" bIns="36576" anchor="ctr">
-            <a:normAutofit/>
+            <a:normAutofit lnSpcReduction="10000"/>
           </a:bodyPr>
           <a:lstStyle/>
           <a:p>
@@ -16782,7 +16888,7 @@
         </p:spPr>
         <p:txBody>
           <a:bodyPr wrap="square" lIns="73152" tIns="36576" rIns="73152" bIns="36576" anchor="ctr">
-            <a:normAutofit/>
+            <a:normAutofit lnSpcReduction="10000"/>
           </a:bodyPr>
           <a:lstStyle/>
           <a:p>
@@ -16992,7 +17098,7 @@
         </p:spPr>
         <p:txBody>
           <a:bodyPr wrap="square" lIns="73152" tIns="36576" rIns="73152" bIns="36576" anchor="ctr">
-            <a:normAutofit/>
+            <a:normAutofit lnSpcReduction="10000"/>
           </a:bodyPr>
           <a:lstStyle/>
           <a:p>
@@ -17164,7 +17270,7 @@
         </p:spPr>
         <p:txBody>
           <a:bodyPr wrap="square" lIns="73152" tIns="36576" rIns="73152" bIns="36576" anchor="ctr">
-            <a:normAutofit/>
+            <a:normAutofit lnSpcReduction="10000"/>
           </a:bodyPr>
           <a:lstStyle/>
           <a:p>
@@ -17336,7 +17442,7 @@
         </p:spPr>
         <p:txBody>
           <a:bodyPr wrap="square" lIns="73152" tIns="36576" rIns="73152" bIns="36576" anchor="ctr">
-            <a:normAutofit/>
+            <a:normAutofit lnSpcReduction="10000"/>
           </a:bodyPr>
           <a:lstStyle/>
           <a:p>
@@ -17460,7 +17566,7 @@
         </p:spPr>
         <p:txBody>
           <a:bodyPr wrap="square" lIns="73152" tIns="36576" rIns="73152" bIns="36576" anchor="ctr">
-            <a:normAutofit/>
+            <a:normAutofit fontScale="92500" lnSpcReduction="10000"/>
           </a:bodyPr>
           <a:lstStyle/>
           <a:p>
@@ -17498,7 +17604,7 @@
         </p:spPr>
         <p:txBody>
           <a:bodyPr wrap="square" lIns="73152" tIns="36576" rIns="73152" bIns="36576" anchor="ctr">
-            <a:normAutofit/>
+            <a:normAutofit fontScale="92500" lnSpcReduction="10000"/>
           </a:bodyPr>
           <a:lstStyle/>
           <a:p>
@@ -17574,7 +17680,7 @@
         </p:spPr>
         <p:txBody>
           <a:bodyPr wrap="square" lIns="73152" tIns="36576" rIns="73152" bIns="36576" anchor="ctr">
-            <a:normAutofit/>
+            <a:normAutofit fontScale="92500" lnSpcReduction="10000"/>
           </a:bodyPr>
           <a:lstStyle/>
           <a:p>
@@ -17650,7 +17756,7 @@
         </p:spPr>
         <p:txBody>
           <a:bodyPr wrap="square" lIns="73152" tIns="36576" rIns="73152" bIns="36576" anchor="ctr">
-            <a:normAutofit/>
+            <a:normAutofit fontScale="92500" lnSpcReduction="10000"/>
           </a:bodyPr>
           <a:lstStyle/>
           <a:p>
@@ -17726,7 +17832,7 @@
         </p:spPr>
         <p:txBody>
           <a:bodyPr wrap="square" lIns="73152" tIns="36576" rIns="73152" bIns="36576" anchor="ctr">
-            <a:normAutofit/>
+            <a:normAutofit fontScale="92500" lnSpcReduction="10000"/>
           </a:bodyPr>
           <a:lstStyle/>
           <a:p>

</xml_diff>